<commit_message>
Update presentation: three-box geometry slide, newest figure, current slide text
</commit_message>
<xml_diff>
--- a/deck/midproject_outline.pptx
+++ b/deck/midproject_outline.pptx
@@ -2068,7 +2068,7 @@
                 <a:ea typeface="Times New Roman" pitchFamily="34" charset="-122"/>
                 <a:cs typeface="Times New Roman" pitchFamily="34" charset="-120"/>
               </a:rPr>
-              <a:t>September 2026 · 8 slides, 6:40 + buffer</a:t>
+              <a:t>September 2026</a:t>
             </a:r>
             <a:endParaRPr lang="en-US" sz="1100" dirty="0"/>
           </a:p>
@@ -2397,7 +2397,7 @@
                 <a:ea typeface="Times New Roman" pitchFamily="34" charset="-122"/>
                 <a:cs typeface="Times New Roman" pitchFamily="34" charset="-120"/>
               </a:rPr>
-              <a:t>[TODO], tied back to an exploration finding (slides 3–5)</a:t>
+              <a:t>[TODO], tied back to an exploration finding (slides 3–6)</a:t>
             </a:r>
             <a:endParaRPr lang="en-US" sz="1200" dirty="0"/>
           </a:p>
@@ -3318,7 +3318,7 @@
                 <a:ea typeface="Times New Roman" pitchFamily="34" charset="-122"/>
                 <a:cs typeface="Times New Roman" pitchFamily="34" charset="-120"/>
               </a:rPr>
-              <a:t>APPENDIX A — BACKUP, NOT IN THE TIMED 6:40</a:t>
+              <a:t>APPENDIX A — BACKUP, NOT IN THE TIMED TALK</a:t>
             </a:r>
             <a:endParaRPr lang="en-US" sz="1200" dirty="0"/>
           </a:p>
@@ -3470,7 +3470,7 @@
                 <a:ea typeface="Times New Roman" pitchFamily="34" charset="-122"/>
                 <a:cs typeface="Times New Roman" pitchFamily="34" charset="-120"/>
               </a:rPr>
-              <a:t>Cut from the main 8 slides for time — pull in only if a question opens the door</a:t>
+              <a:t>Backup only — pull in if a question opens the door</a:t>
             </a:r>
             <a:endParaRPr lang="en-US" sz="1600" dirty="0"/>
           </a:p>
@@ -4514,7 +4514,7 @@
                 <a:ea typeface="Times New Roman" pitchFamily="34" charset="-122"/>
                 <a:cs typeface="Times New Roman" pitchFamily="34" charset="-120"/>
               </a:rPr>
-              <a:t>Exploratory Analysis I: Acquisition Geometry</a:t>
+              <a:t>Exploratory Analysis I: Scan Geometry for the 20 CT Scans</a:t>
             </a:r>
             <a:endParaRPr lang="en-US" sz="2600" dirty="0"/>
           </a:p>
@@ -4545,115 +4545,14 @@
       </p:pic>
       <p:sp>
         <p:nvSpPr>
-          <p:cNvPr id="7" name="Text 4"/>
-          <p:cNvSpPr txBox="1"/>
-          <p:nvPr/>
-        </p:nvSpPr>
-        <p:spPr>
-          <a:xfrm>
-            <a:off x="9418320" y="1234440"/>
-            <a:ext cx="2331720" cy="256032"/>
-          </a:xfrm>
-          <a:prstGeom prst="rect">
-            <a:avLst/>
-          </a:prstGeom>
-          <a:noFill/>
-          <a:ln/>
-        </p:spPr>
-        <p:txBody>
-          <a:bodyPr wrap="square" lIns="0" tIns="0" rIns="0" bIns="0" rtlCol="0" anchor="ctr"/>
-          <a:lstStyle/>
-          <a:p>
-            <a:pPr indent="0" marL="0">
-              <a:buNone/>
-            </a:pPr>
-            <a:r>
-              <a:rPr lang="en-US" sz="1150" b="1" spc="100" kern="0" dirty="0">
-                <a:solidFill>
-                  <a:srgbClr val="E98300"/>
-                </a:solidFill>
-                <a:latin typeface="Times New Roman" pitchFamily="34" charset="0"/>
-                <a:ea typeface="Times New Roman" pitchFamily="34" charset="-122"/>
-                <a:cs typeface="Times New Roman" pitchFamily="34" charset="-120"/>
-              </a:rPr>
-              <a:t>WHAT IT SHOWS</a:t>
-            </a:r>
-            <a:endParaRPr lang="en-US" sz="1150" dirty="0"/>
-          </a:p>
-        </p:txBody>
-      </p:sp>
-      <p:sp>
-        <p:nvSpPr>
-          <p:cNvPr id="8" name="Text 5"/>
-          <p:cNvSpPr txBox="1"/>
-          <p:nvPr/>
-        </p:nvSpPr>
-        <p:spPr>
-          <a:xfrm>
-            <a:off x="9418320" y="1508760"/>
-            <a:ext cx="2331720" cy="1005840"/>
-          </a:xfrm>
-          <a:prstGeom prst="rect">
-            <a:avLst/>
-          </a:prstGeom>
-          <a:noFill/>
-          <a:ln/>
-        </p:spPr>
-        <p:txBody>
-          <a:bodyPr wrap="square" lIns="0" tIns="0" rIns="0" bIns="0" rtlCol="0" anchor="t"/>
-          <a:lstStyle/>
-          <a:p>
-            <a:pPr indent="0" marL="0">
-              <a:lnSpc>
-                <a:spcPct val="115000"/>
-              </a:lnSpc>
-              <a:buNone/>
-            </a:pPr>
-            <a:r>
-              <a:rPr lang="en-US" sz="1250" dirty="0">
-                <a:solidFill>
-                  <a:srgbClr val="1F1D21"/>
-                </a:solidFill>
-                <a:latin typeface="Times New Roman" pitchFamily="34" charset="0"/>
-                <a:ea typeface="Times New Roman" pitchFamily="34" charset="-122"/>
-                <a:cs typeface="Times New Roman" pitchFamily="34" charset="-120"/>
-              </a:rPr>
-              <a:t>[TODO] voxel spacing across patients</a:t>
-            </a:r>
-            <a:endParaRPr lang="en-US" sz="1250" dirty="0"/>
-          </a:p>
-          <a:p>
-            <a:pPr indent="0" marL="0">
-              <a:lnSpc>
-                <a:spcPct val="115000"/>
-              </a:lnSpc>
-              <a:buNone/>
-            </a:pPr>
-            <a:r>
-              <a:rPr lang="en-US" sz="1250" dirty="0">
-                <a:solidFill>
-                  <a:srgbClr val="1F1D21"/>
-                </a:solidFill>
-                <a:latin typeface="Times New Roman" pitchFamily="34" charset="0"/>
-                <a:ea typeface="Times New Roman" pitchFamily="34" charset="-122"/>
-                <a:cs typeface="Times New Roman" pitchFamily="34" charset="-120"/>
-              </a:rPr>
-              <a:t>[TODO] slice count / scan length</a:t>
-            </a:r>
-            <a:endParaRPr lang="en-US" sz="1250" dirty="0"/>
-          </a:p>
-        </p:txBody>
-      </p:sp>
-      <p:sp>
-        <p:nvSpPr>
-          <p:cNvPr id="9" name="Shape 6"/>
+          <p:cNvPr id="7" name="Shape 4"/>
           <p:cNvSpPr/>
           <p:nvPr/>
         </p:nvSpPr>
         <p:spPr>
           <a:xfrm>
-            <a:off x="9418320" y="2697480"/>
-            <a:ext cx="2331720" cy="3383280"/>
+            <a:off x="8140700" y="1234440"/>
+            <a:ext cx="3609340" cy="1493520"/>
           </a:xfrm>
           <a:prstGeom prst="rect">
             <a:avLst/>
@@ -4666,14 +4565,14 @@
       </p:sp>
       <p:sp>
         <p:nvSpPr>
-          <p:cNvPr id="10" name="Shape 7"/>
+          <p:cNvPr id="8" name="Shape 5"/>
           <p:cNvSpPr/>
           <p:nvPr/>
         </p:nvSpPr>
         <p:spPr>
           <a:xfrm>
-            <a:off x="9418320" y="2697480"/>
-            <a:ext cx="54864" cy="3383280"/>
+            <a:off x="8140700" y="1234440"/>
+            <a:ext cx="54864" cy="1493520"/>
           </a:xfrm>
           <a:prstGeom prst="rect">
             <a:avLst/>
@@ -4686,14 +4585,14 @@
       </p:sp>
       <p:sp>
         <p:nvSpPr>
-          <p:cNvPr id="11" name="Text 8"/>
-          <p:cNvSpPr txBox="1"/>
-          <p:nvPr/>
-        </p:nvSpPr>
-        <p:spPr>
-          <a:xfrm>
-            <a:off x="9692640" y="2880360"/>
-            <a:ext cx="1783080" cy="274320"/>
+          <p:cNvPr id="9" name="Text 6"/>
+          <p:cNvSpPr txBox="1"/>
+          <p:nvPr/>
+        </p:nvSpPr>
+        <p:spPr>
+          <a:xfrm>
+            <a:off x="8415020" y="1417320"/>
+            <a:ext cx="3060700" cy="274320"/>
           </a:xfrm>
           <a:prstGeom prst="rect">
             <a:avLst/>
@@ -4717,7 +4616,7 @@
                 <a:ea typeface="Times New Roman" pitchFamily="34" charset="-122"/>
                 <a:cs typeface="Times New Roman" pitchFamily="34" charset="-120"/>
               </a:rPr>
-              <a:t>WHAT WE LEARN</a:t>
+              <a:t>WHAT IT SHOWS</a:t>
             </a:r>
             <a:endParaRPr lang="en-US" sz="1100" dirty="0"/>
           </a:p>
@@ -4725,14 +4624,14 @@
       </p:sp>
       <p:sp>
         <p:nvSpPr>
-          <p:cNvPr id="12" name="Text 9"/>
-          <p:cNvSpPr txBox="1"/>
-          <p:nvPr/>
-        </p:nvSpPr>
-        <p:spPr>
-          <a:xfrm>
-            <a:off x="9692640" y="3200400"/>
-            <a:ext cx="1783080" cy="2697480"/>
+          <p:cNvPr id="10" name="Text 7"/>
+          <p:cNvSpPr txBox="1"/>
+          <p:nvPr/>
+        </p:nvSpPr>
+        <p:spPr>
+          <a:xfrm>
+            <a:off x="8415020" y="1737360"/>
+            <a:ext cx="3060700" cy="807720"/>
           </a:xfrm>
           <a:prstGeom prst="rect">
             <a:avLst/>
@@ -4759,6 +4658,248 @@
                 <a:ea typeface="Times New Roman" pitchFamily="34" charset="-122"/>
                 <a:cs typeface="Times New Roman" pitchFamily="34" charset="-120"/>
               </a:rPr>
+              <a:t>[TODO] voxel spacing across patients, slice count / scan length</a:t>
+            </a:r>
+            <a:endParaRPr lang="en-US" sz="1350" dirty="0"/>
+          </a:p>
+        </p:txBody>
+      </p:sp>
+      <p:sp>
+        <p:nvSpPr>
+          <p:cNvPr id="11" name="Shape 8"/>
+          <p:cNvSpPr/>
+          <p:nvPr/>
+        </p:nvSpPr>
+        <p:spPr>
+          <a:xfrm>
+            <a:off x="8140700" y="2910840"/>
+            <a:ext cx="3609340" cy="1493520"/>
+          </a:xfrm>
+          <a:prstGeom prst="rect">
+            <a:avLst/>
+          </a:prstGeom>
+          <a:solidFill>
+            <a:srgbClr val="F7E8EC"/>
+          </a:solidFill>
+          <a:ln/>
+        </p:spPr>
+      </p:sp>
+      <p:sp>
+        <p:nvSpPr>
+          <p:cNvPr id="12" name="Shape 9"/>
+          <p:cNvSpPr/>
+          <p:nvPr/>
+        </p:nvSpPr>
+        <p:spPr>
+          <a:xfrm>
+            <a:off x="8140700" y="2910840"/>
+            <a:ext cx="54864" cy="1493520"/>
+          </a:xfrm>
+          <a:prstGeom prst="rect">
+            <a:avLst/>
+          </a:prstGeom>
+          <a:solidFill>
+            <a:srgbClr val="BC0031"/>
+          </a:solidFill>
+          <a:ln/>
+        </p:spPr>
+      </p:sp>
+      <p:sp>
+        <p:nvSpPr>
+          <p:cNvPr id="13" name="Text 10"/>
+          <p:cNvSpPr txBox="1"/>
+          <p:nvPr/>
+        </p:nvSpPr>
+        <p:spPr>
+          <a:xfrm>
+            <a:off x="8415020" y="3093720"/>
+            <a:ext cx="3060700" cy="274320"/>
+          </a:xfrm>
+          <a:prstGeom prst="rect">
+            <a:avLst/>
+          </a:prstGeom>
+          <a:noFill/>
+          <a:ln/>
+        </p:spPr>
+        <p:txBody>
+          <a:bodyPr wrap="square" lIns="0" tIns="0" rIns="0" bIns="0" rtlCol="0" anchor="ctr"/>
+          <a:lstStyle/>
+          <a:p>
+            <a:pPr indent="0" marL="0">
+              <a:buNone/>
+            </a:pPr>
+            <a:r>
+              <a:rPr lang="en-US" sz="1100" b="1" spc="100" kern="0" dirty="0">
+                <a:solidFill>
+                  <a:srgbClr val="BC0031"/>
+                </a:solidFill>
+                <a:latin typeface="Times New Roman" pitchFamily="34" charset="0"/>
+                <a:ea typeface="Times New Roman" pitchFamily="34" charset="-122"/>
+                <a:cs typeface="Times New Roman" pitchFamily="34" charset="-120"/>
+              </a:rPr>
+              <a:t>HOW IT WAS MADE</a:t>
+            </a:r>
+            <a:endParaRPr lang="en-US" sz="1100" dirty="0"/>
+          </a:p>
+        </p:txBody>
+      </p:sp>
+      <p:sp>
+        <p:nvSpPr>
+          <p:cNvPr id="14" name="Text 11"/>
+          <p:cNvSpPr txBox="1"/>
+          <p:nvPr/>
+        </p:nvSpPr>
+        <p:spPr>
+          <a:xfrm>
+            <a:off x="8415020" y="3413760"/>
+            <a:ext cx="3060700" cy="807720"/>
+          </a:xfrm>
+          <a:prstGeom prst="rect">
+            <a:avLst/>
+          </a:prstGeom>
+          <a:noFill/>
+          <a:ln/>
+        </p:spPr>
+        <p:txBody>
+          <a:bodyPr wrap="square" lIns="0" tIns="0" rIns="0" bIns="0" rtlCol="0" anchor="t"/>
+          <a:lstStyle/>
+          <a:p>
+            <a:pPr indent="0" marL="0">
+              <a:lnSpc>
+                <a:spcPct val="118000"/>
+              </a:lnSpc>
+              <a:buNone/>
+            </a:pPr>
+            <a:r>
+              <a:rPr lang="en-US" sz="1350" dirty="0">
+                <a:solidFill>
+                  <a:srgbClr val="1F1D21"/>
+                </a:solidFill>
+                <a:latin typeface="Times New Roman" pitchFamily="34" charset="0"/>
+                <a:ea typeface="Times New Roman" pitchFamily="34" charset="-122"/>
+                <a:cs typeface="Times New Roman" pitchFamily="34" charset="-120"/>
+              </a:rPr>
+              <a:t>[TODO] how it was measured</a:t>
+            </a:r>
+            <a:endParaRPr lang="en-US" sz="1350" dirty="0"/>
+          </a:p>
+        </p:txBody>
+      </p:sp>
+      <p:sp>
+        <p:nvSpPr>
+          <p:cNvPr id="15" name="Shape 12"/>
+          <p:cNvSpPr/>
+          <p:nvPr/>
+        </p:nvSpPr>
+        <p:spPr>
+          <a:xfrm>
+            <a:off x="8140700" y="4587240"/>
+            <a:ext cx="3609340" cy="1493520"/>
+          </a:xfrm>
+          <a:prstGeom prst="rect">
+            <a:avLst/>
+          </a:prstGeom>
+          <a:solidFill>
+            <a:srgbClr val="F1E6EF"/>
+          </a:solidFill>
+          <a:ln/>
+        </p:spPr>
+      </p:sp>
+      <p:sp>
+        <p:nvSpPr>
+          <p:cNvPr id="16" name="Shape 13"/>
+          <p:cNvSpPr/>
+          <p:nvPr/>
+        </p:nvSpPr>
+        <p:spPr>
+          <a:xfrm>
+            <a:off x="8140700" y="4587240"/>
+            <a:ext cx="54864" cy="1493520"/>
+          </a:xfrm>
+          <a:prstGeom prst="rect">
+            <a:avLst/>
+          </a:prstGeom>
+          <a:solidFill>
+            <a:srgbClr val="751B68"/>
+          </a:solidFill>
+          <a:ln/>
+        </p:spPr>
+      </p:sp>
+      <p:sp>
+        <p:nvSpPr>
+          <p:cNvPr id="17" name="Text 14"/>
+          <p:cNvSpPr txBox="1"/>
+          <p:nvPr/>
+        </p:nvSpPr>
+        <p:spPr>
+          <a:xfrm>
+            <a:off x="8415020" y="4770120"/>
+            <a:ext cx="3060700" cy="274320"/>
+          </a:xfrm>
+          <a:prstGeom prst="rect">
+            <a:avLst/>
+          </a:prstGeom>
+          <a:noFill/>
+          <a:ln/>
+        </p:spPr>
+        <p:txBody>
+          <a:bodyPr wrap="square" lIns="0" tIns="0" rIns="0" bIns="0" rtlCol="0" anchor="ctr"/>
+          <a:lstStyle/>
+          <a:p>
+            <a:pPr indent="0" marL="0">
+              <a:buNone/>
+            </a:pPr>
+            <a:r>
+              <a:rPr lang="en-US" sz="1100" b="1" spc="100" kern="0" dirty="0">
+                <a:solidFill>
+                  <a:srgbClr val="751B68"/>
+                </a:solidFill>
+                <a:latin typeface="Times New Roman" pitchFamily="34" charset="0"/>
+                <a:ea typeface="Times New Roman" pitchFamily="34" charset="-122"/>
+                <a:cs typeface="Times New Roman" pitchFamily="34" charset="-120"/>
+              </a:rPr>
+              <a:t>WHAT WE LEARN</a:t>
+            </a:r>
+            <a:endParaRPr lang="en-US" sz="1100" dirty="0"/>
+          </a:p>
+        </p:txBody>
+      </p:sp>
+      <p:sp>
+        <p:nvSpPr>
+          <p:cNvPr id="18" name="Text 15"/>
+          <p:cNvSpPr txBox="1"/>
+          <p:nvPr/>
+        </p:nvSpPr>
+        <p:spPr>
+          <a:xfrm>
+            <a:off x="8415020" y="5090160"/>
+            <a:ext cx="3060700" cy="807720"/>
+          </a:xfrm>
+          <a:prstGeom prst="rect">
+            <a:avLst/>
+          </a:prstGeom>
+          <a:noFill/>
+          <a:ln/>
+        </p:spPr>
+        <p:txBody>
+          <a:bodyPr wrap="square" lIns="0" tIns="0" rIns="0" bIns="0" rtlCol="0" anchor="t"/>
+          <a:lstStyle/>
+          <a:p>
+            <a:pPr indent="0" marL="0">
+              <a:lnSpc>
+                <a:spcPct val="118000"/>
+              </a:lnSpc>
+              <a:buNone/>
+            </a:pPr>
+            <a:r>
+              <a:rPr lang="en-US" sz="1350" dirty="0">
+                <a:solidFill>
+                  <a:srgbClr val="1F1D21"/>
+                </a:solidFill>
+                <a:latin typeface="Times New Roman" pitchFamily="34" charset="0"/>
+                <a:ea typeface="Times New Roman" pitchFamily="34" charset="-122"/>
+                <a:cs typeface="Times New Roman" pitchFamily="34" charset="-120"/>
+              </a:rPr>
               <a:t>[TODO] what this implies</a:t>
             </a:r>
             <a:endParaRPr lang="en-US" sz="1350" dirty="0"/>
@@ -4767,7 +4908,7 @@
       </p:sp>
       <p:pic>
         <p:nvPicPr>
-          <p:cNvPr id="13" name="Image 1" descr="/Users/bellavg/ProjectsMSc/ai4mi_project/deck/assets/uva_logo.png">    </p:cNvPr>
+          <p:cNvPr id="19" name="Image 1" descr="/Users/bellavg/ProjectsMSc/ai4mi_project/deck/assets/uva_logo.png">    </p:cNvPr>
           <p:cNvPicPr>
             <a:picLocks noChangeAspect="1"/>
           </p:cNvPicPr>
@@ -4791,7 +4932,7 @@
       </p:pic>
       <p:sp>
         <p:nvSpPr>
-          <p:cNvPr id="14" name="Text 10"/>
+          <p:cNvPr id="20" name="Text 16"/>
           <p:cNvSpPr txBox="1"/>
           <p:nvPr/>
         </p:nvSpPr>
@@ -5057,7 +5198,7 @@
                 <a:ea typeface="Times New Roman" pitchFamily="34" charset="-122"/>
                 <a:cs typeface="Times New Roman" pitchFamily="34" charset="-120"/>
               </a:rPr>
-              <a:t>[TODO] whole-scan HU distribution</a:t>
+              <a:t>[TODO] whole-scan HU distribution, with each organ's voxels coloured</a:t>
             </a:r>
             <a:endParaRPr lang="en-US" sz="1600" dirty="0"/>
           </a:p>
@@ -5081,7 +5222,7 @@
                 <a:ea typeface="Times New Roman" pitchFamily="34" charset="-122"/>
                 <a:cs typeface="Times New Roman" pitchFamily="34" charset="-120"/>
               </a:rPr>
-              <a:t>[TODO] per-organ HU, esp. aorta vs. heart</a:t>
+              <a:t>[TODO] aorta vs. heart in HU</a:t>
             </a:r>
             <a:endParaRPr lang="en-US" sz="1600" dirty="0"/>
           </a:p>
@@ -6710,7 +6851,7 @@
                 <a:ea typeface="Times New Roman" pitchFamily="34" charset="-122"/>
                 <a:cs typeface="Times New Roman" pitchFamily="34" charset="-120"/>
               </a:rPr>
-              <a:t>[TODO], motivated by the intensity measurement (slide 3)</a:t>
+              <a:t>[TODO], motivated by the intensity measurement (slide 4)</a:t>
             </a:r>
             <a:endParaRPr lang="en-US" sz="1200" dirty="0"/>
           </a:p>
@@ -6870,7 +7011,7 @@
                 <a:ea typeface="Times New Roman" pitchFamily="34" charset="-122"/>
                 <a:cs typeface="Times New Roman" pitchFamily="34" charset="-120"/>
               </a:rPr>
-              <a:t>[TODO], motivated by the position/extent measurement (slide 5)</a:t>
+              <a:t>[TODO], motivated by the position/extent measurement (slide 6)</a:t>
             </a:r>
             <a:endParaRPr lang="en-US" sz="1200" dirty="0"/>
           </a:p>

</xml_diff>

<commit_message>
Use one tinted box on the geometry slide, plain coloured titles above it
</commit_message>
<xml_diff>
--- a/deck/midproject_outline.pptx
+++ b/deck/midproject_outline.pptx
@@ -4545,14 +4545,176 @@
       </p:pic>
       <p:sp>
         <p:nvSpPr>
-          <p:cNvPr id="7" name="Shape 4"/>
+          <p:cNvPr id="7" name="Text 4"/>
+          <p:cNvSpPr txBox="1"/>
+          <p:nvPr/>
+        </p:nvSpPr>
+        <p:spPr>
+          <a:xfrm>
+            <a:off x="8140700" y="1234440"/>
+            <a:ext cx="3609340" cy="256032"/>
+          </a:xfrm>
+          <a:prstGeom prst="rect">
+            <a:avLst/>
+          </a:prstGeom>
+          <a:noFill/>
+          <a:ln/>
+        </p:spPr>
+        <p:txBody>
+          <a:bodyPr wrap="square" lIns="0" tIns="0" rIns="0" bIns="0" rtlCol="0" anchor="ctr"/>
+          <a:lstStyle/>
+          <a:p>
+            <a:pPr indent="0" marL="0">
+              <a:buNone/>
+            </a:pPr>
+            <a:r>
+              <a:rPr lang="en-US" sz="1150" b="1" spc="100" kern="0" dirty="0">
+                <a:solidFill>
+                  <a:srgbClr val="E98300"/>
+                </a:solidFill>
+                <a:latin typeface="Times New Roman" pitchFamily="34" charset="0"/>
+                <a:ea typeface="Times New Roman" pitchFamily="34" charset="-122"/>
+                <a:cs typeface="Times New Roman" pitchFamily="34" charset="-120"/>
+              </a:rPr>
+              <a:t>WHAT IT SHOWS</a:t>
+            </a:r>
+            <a:endParaRPr lang="en-US" sz="1150" dirty="0"/>
+          </a:p>
+        </p:txBody>
+      </p:sp>
+      <p:sp>
+        <p:nvSpPr>
+          <p:cNvPr id="8" name="Text 5"/>
+          <p:cNvSpPr txBox="1"/>
+          <p:nvPr/>
+        </p:nvSpPr>
+        <p:spPr>
+          <a:xfrm>
+            <a:off x="8140700" y="1527048"/>
+            <a:ext cx="3609340" cy="960120"/>
+          </a:xfrm>
+          <a:prstGeom prst="rect">
+            <a:avLst/>
+          </a:prstGeom>
+          <a:noFill/>
+          <a:ln/>
+        </p:spPr>
+        <p:txBody>
+          <a:bodyPr wrap="square" lIns="0" tIns="0" rIns="0" bIns="0" rtlCol="0" anchor="t"/>
+          <a:lstStyle/>
+          <a:p>
+            <a:pPr indent="0" marL="0">
+              <a:lnSpc>
+                <a:spcPct val="115000"/>
+              </a:lnSpc>
+              <a:buNone/>
+            </a:pPr>
+            <a:r>
+              <a:rPr lang="en-US" sz="1250" dirty="0">
+                <a:solidFill>
+                  <a:srgbClr val="1F1D21"/>
+                </a:solidFill>
+                <a:latin typeface="Times New Roman" pitchFamily="34" charset="0"/>
+                <a:ea typeface="Times New Roman" pitchFamily="34" charset="-122"/>
+                <a:cs typeface="Times New Roman" pitchFamily="34" charset="-120"/>
+              </a:rPr>
+              <a:t>[TODO] voxel spacing across patients, slice count / scan length</a:t>
+            </a:r>
+            <a:endParaRPr lang="en-US" sz="1250" dirty="0"/>
+          </a:p>
+        </p:txBody>
+      </p:sp>
+      <p:sp>
+        <p:nvSpPr>
+          <p:cNvPr id="9" name="Text 6"/>
+          <p:cNvSpPr txBox="1"/>
+          <p:nvPr/>
+        </p:nvSpPr>
+        <p:spPr>
+          <a:xfrm>
+            <a:off x="8140700" y="2651760"/>
+            <a:ext cx="3609340" cy="256032"/>
+          </a:xfrm>
+          <a:prstGeom prst="rect">
+            <a:avLst/>
+          </a:prstGeom>
+          <a:noFill/>
+          <a:ln/>
+        </p:spPr>
+        <p:txBody>
+          <a:bodyPr wrap="square" lIns="0" tIns="0" rIns="0" bIns="0" rtlCol="0" anchor="ctr"/>
+          <a:lstStyle/>
+          <a:p>
+            <a:pPr indent="0" marL="0">
+              <a:buNone/>
+            </a:pPr>
+            <a:r>
+              <a:rPr lang="en-US" sz="1150" b="1" spc="100" kern="0" dirty="0">
+                <a:solidFill>
+                  <a:srgbClr val="BC0031"/>
+                </a:solidFill>
+                <a:latin typeface="Times New Roman" pitchFamily="34" charset="0"/>
+                <a:ea typeface="Times New Roman" pitchFamily="34" charset="-122"/>
+                <a:cs typeface="Times New Roman" pitchFamily="34" charset="-120"/>
+              </a:rPr>
+              <a:t>HOW IT WAS MADE</a:t>
+            </a:r>
+            <a:endParaRPr lang="en-US" sz="1150" dirty="0"/>
+          </a:p>
+        </p:txBody>
+      </p:sp>
+      <p:sp>
+        <p:nvSpPr>
+          <p:cNvPr id="10" name="Text 7"/>
+          <p:cNvSpPr txBox="1"/>
+          <p:nvPr/>
+        </p:nvSpPr>
+        <p:spPr>
+          <a:xfrm>
+            <a:off x="8140700" y="2944368"/>
+            <a:ext cx="3609340" cy="960120"/>
+          </a:xfrm>
+          <a:prstGeom prst="rect">
+            <a:avLst/>
+          </a:prstGeom>
+          <a:noFill/>
+          <a:ln/>
+        </p:spPr>
+        <p:txBody>
+          <a:bodyPr wrap="square" lIns="0" tIns="0" rIns="0" bIns="0" rtlCol="0" anchor="t"/>
+          <a:lstStyle/>
+          <a:p>
+            <a:pPr indent="0" marL="0">
+              <a:lnSpc>
+                <a:spcPct val="115000"/>
+              </a:lnSpc>
+              <a:buNone/>
+            </a:pPr>
+            <a:r>
+              <a:rPr lang="en-US" sz="1250" dirty="0">
+                <a:solidFill>
+                  <a:srgbClr val="1F1D21"/>
+                </a:solidFill>
+                <a:latin typeface="Times New Roman" pitchFamily="34" charset="0"/>
+                <a:ea typeface="Times New Roman" pitchFamily="34" charset="-122"/>
+                <a:cs typeface="Times New Roman" pitchFamily="34" charset="-120"/>
+              </a:rPr>
+              <a:t>[TODO] how it was measured</a:t>
+            </a:r>
+            <a:endParaRPr lang="en-US" sz="1250" dirty="0"/>
+          </a:p>
+        </p:txBody>
+      </p:sp>
+      <p:sp>
+        <p:nvSpPr>
+          <p:cNvPr id="11" name="Shape 8"/>
           <p:cNvSpPr/>
           <p:nvPr/>
         </p:nvSpPr>
         <p:spPr>
           <a:xfrm>
-            <a:off x="8140700" y="1234440"/>
-            <a:ext cx="3609340" cy="1493520"/>
+            <a:off x="8140700" y="4526280"/>
+            <a:ext cx="3609340" cy="1554480"/>
           </a:xfrm>
           <a:prstGeom prst="rect">
             <a:avLst/>
@@ -4565,14 +4727,14 @@
       </p:sp>
       <p:sp>
         <p:nvSpPr>
-          <p:cNvPr id="8" name="Shape 5"/>
+          <p:cNvPr id="12" name="Shape 9"/>
           <p:cNvSpPr/>
           <p:nvPr/>
         </p:nvSpPr>
         <p:spPr>
           <a:xfrm>
-            <a:off x="8140700" y="1234440"/>
-            <a:ext cx="54864" cy="1493520"/>
+            <a:off x="8140700" y="4526280"/>
+            <a:ext cx="54864" cy="1554480"/>
           </a:xfrm>
           <a:prstGeom prst="rect">
             <a:avLst/>
@@ -4585,13 +4747,13 @@
       </p:sp>
       <p:sp>
         <p:nvSpPr>
-          <p:cNvPr id="9" name="Text 6"/>
-          <p:cNvSpPr txBox="1"/>
-          <p:nvPr/>
-        </p:nvSpPr>
-        <p:spPr>
-          <a:xfrm>
-            <a:off x="8415020" y="1417320"/>
+          <p:cNvPr id="13" name="Text 10"/>
+          <p:cNvSpPr txBox="1"/>
+          <p:nvPr/>
+        </p:nvSpPr>
+        <p:spPr>
+          <a:xfrm>
+            <a:off x="8415020" y="4709160"/>
             <a:ext cx="3060700" cy="274320"/>
           </a:xfrm>
           <a:prstGeom prst="rect">
@@ -4610,13 +4772,13 @@
             <a:r>
               <a:rPr lang="en-US" sz="1100" b="1" spc="100" kern="0" dirty="0">
                 <a:solidFill>
-                  <a:srgbClr val="E98300"/>
-                </a:solidFill>
-                <a:latin typeface="Times New Roman" pitchFamily="34" charset="0"/>
-                <a:ea typeface="Times New Roman" pitchFamily="34" charset="-122"/>
-                <a:cs typeface="Times New Roman" pitchFamily="34" charset="-120"/>
-              </a:rPr>
-              <a:t>WHAT IT SHOWS</a:t>
+                  <a:srgbClr val="1F1D21"/>
+                </a:solidFill>
+                <a:latin typeface="Times New Roman" pitchFamily="34" charset="0"/>
+                <a:ea typeface="Times New Roman" pitchFamily="34" charset="-122"/>
+                <a:cs typeface="Times New Roman" pitchFamily="34" charset="-120"/>
+              </a:rPr>
+              <a:t>WHAT WE LEARN</a:t>
             </a:r>
             <a:endParaRPr lang="en-US" sz="1100" dirty="0"/>
           </a:p>
@@ -4624,14 +4786,14 @@
       </p:sp>
       <p:sp>
         <p:nvSpPr>
-          <p:cNvPr id="10" name="Text 7"/>
-          <p:cNvSpPr txBox="1"/>
-          <p:nvPr/>
-        </p:nvSpPr>
-        <p:spPr>
-          <a:xfrm>
-            <a:off x="8415020" y="1737360"/>
-            <a:ext cx="3060700" cy="807720"/>
+          <p:cNvPr id="14" name="Text 11"/>
+          <p:cNvSpPr txBox="1"/>
+          <p:nvPr/>
+        </p:nvSpPr>
+        <p:spPr>
+          <a:xfrm>
+            <a:off x="8415020" y="5029200"/>
+            <a:ext cx="3060700" cy="868680"/>
           </a:xfrm>
           <a:prstGeom prst="rect">
             <a:avLst/>
@@ -4658,248 +4820,6 @@
                 <a:ea typeface="Times New Roman" pitchFamily="34" charset="-122"/>
                 <a:cs typeface="Times New Roman" pitchFamily="34" charset="-120"/>
               </a:rPr>
-              <a:t>[TODO] voxel spacing across patients, slice count / scan length</a:t>
-            </a:r>
-            <a:endParaRPr lang="en-US" sz="1350" dirty="0"/>
-          </a:p>
-        </p:txBody>
-      </p:sp>
-      <p:sp>
-        <p:nvSpPr>
-          <p:cNvPr id="11" name="Shape 8"/>
-          <p:cNvSpPr/>
-          <p:nvPr/>
-        </p:nvSpPr>
-        <p:spPr>
-          <a:xfrm>
-            <a:off x="8140700" y="2910840"/>
-            <a:ext cx="3609340" cy="1493520"/>
-          </a:xfrm>
-          <a:prstGeom prst="rect">
-            <a:avLst/>
-          </a:prstGeom>
-          <a:solidFill>
-            <a:srgbClr val="F7E8EC"/>
-          </a:solidFill>
-          <a:ln/>
-        </p:spPr>
-      </p:sp>
-      <p:sp>
-        <p:nvSpPr>
-          <p:cNvPr id="12" name="Shape 9"/>
-          <p:cNvSpPr/>
-          <p:nvPr/>
-        </p:nvSpPr>
-        <p:spPr>
-          <a:xfrm>
-            <a:off x="8140700" y="2910840"/>
-            <a:ext cx="54864" cy="1493520"/>
-          </a:xfrm>
-          <a:prstGeom prst="rect">
-            <a:avLst/>
-          </a:prstGeom>
-          <a:solidFill>
-            <a:srgbClr val="BC0031"/>
-          </a:solidFill>
-          <a:ln/>
-        </p:spPr>
-      </p:sp>
-      <p:sp>
-        <p:nvSpPr>
-          <p:cNvPr id="13" name="Text 10"/>
-          <p:cNvSpPr txBox="1"/>
-          <p:nvPr/>
-        </p:nvSpPr>
-        <p:spPr>
-          <a:xfrm>
-            <a:off x="8415020" y="3093720"/>
-            <a:ext cx="3060700" cy="274320"/>
-          </a:xfrm>
-          <a:prstGeom prst="rect">
-            <a:avLst/>
-          </a:prstGeom>
-          <a:noFill/>
-          <a:ln/>
-        </p:spPr>
-        <p:txBody>
-          <a:bodyPr wrap="square" lIns="0" tIns="0" rIns="0" bIns="0" rtlCol="0" anchor="ctr"/>
-          <a:lstStyle/>
-          <a:p>
-            <a:pPr indent="0" marL="0">
-              <a:buNone/>
-            </a:pPr>
-            <a:r>
-              <a:rPr lang="en-US" sz="1100" b="1" spc="100" kern="0" dirty="0">
-                <a:solidFill>
-                  <a:srgbClr val="BC0031"/>
-                </a:solidFill>
-                <a:latin typeface="Times New Roman" pitchFamily="34" charset="0"/>
-                <a:ea typeface="Times New Roman" pitchFamily="34" charset="-122"/>
-                <a:cs typeface="Times New Roman" pitchFamily="34" charset="-120"/>
-              </a:rPr>
-              <a:t>HOW IT WAS MADE</a:t>
-            </a:r>
-            <a:endParaRPr lang="en-US" sz="1100" dirty="0"/>
-          </a:p>
-        </p:txBody>
-      </p:sp>
-      <p:sp>
-        <p:nvSpPr>
-          <p:cNvPr id="14" name="Text 11"/>
-          <p:cNvSpPr txBox="1"/>
-          <p:nvPr/>
-        </p:nvSpPr>
-        <p:spPr>
-          <a:xfrm>
-            <a:off x="8415020" y="3413760"/>
-            <a:ext cx="3060700" cy="807720"/>
-          </a:xfrm>
-          <a:prstGeom prst="rect">
-            <a:avLst/>
-          </a:prstGeom>
-          <a:noFill/>
-          <a:ln/>
-        </p:spPr>
-        <p:txBody>
-          <a:bodyPr wrap="square" lIns="0" tIns="0" rIns="0" bIns="0" rtlCol="0" anchor="t"/>
-          <a:lstStyle/>
-          <a:p>
-            <a:pPr indent="0" marL="0">
-              <a:lnSpc>
-                <a:spcPct val="118000"/>
-              </a:lnSpc>
-              <a:buNone/>
-            </a:pPr>
-            <a:r>
-              <a:rPr lang="en-US" sz="1350" dirty="0">
-                <a:solidFill>
-                  <a:srgbClr val="1F1D21"/>
-                </a:solidFill>
-                <a:latin typeface="Times New Roman" pitchFamily="34" charset="0"/>
-                <a:ea typeface="Times New Roman" pitchFamily="34" charset="-122"/>
-                <a:cs typeface="Times New Roman" pitchFamily="34" charset="-120"/>
-              </a:rPr>
-              <a:t>[TODO] how it was measured</a:t>
-            </a:r>
-            <a:endParaRPr lang="en-US" sz="1350" dirty="0"/>
-          </a:p>
-        </p:txBody>
-      </p:sp>
-      <p:sp>
-        <p:nvSpPr>
-          <p:cNvPr id="15" name="Shape 12"/>
-          <p:cNvSpPr/>
-          <p:nvPr/>
-        </p:nvSpPr>
-        <p:spPr>
-          <a:xfrm>
-            <a:off x="8140700" y="4587240"/>
-            <a:ext cx="3609340" cy="1493520"/>
-          </a:xfrm>
-          <a:prstGeom prst="rect">
-            <a:avLst/>
-          </a:prstGeom>
-          <a:solidFill>
-            <a:srgbClr val="F1E6EF"/>
-          </a:solidFill>
-          <a:ln/>
-        </p:spPr>
-      </p:sp>
-      <p:sp>
-        <p:nvSpPr>
-          <p:cNvPr id="16" name="Shape 13"/>
-          <p:cNvSpPr/>
-          <p:nvPr/>
-        </p:nvSpPr>
-        <p:spPr>
-          <a:xfrm>
-            <a:off x="8140700" y="4587240"/>
-            <a:ext cx="54864" cy="1493520"/>
-          </a:xfrm>
-          <a:prstGeom prst="rect">
-            <a:avLst/>
-          </a:prstGeom>
-          <a:solidFill>
-            <a:srgbClr val="751B68"/>
-          </a:solidFill>
-          <a:ln/>
-        </p:spPr>
-      </p:sp>
-      <p:sp>
-        <p:nvSpPr>
-          <p:cNvPr id="17" name="Text 14"/>
-          <p:cNvSpPr txBox="1"/>
-          <p:nvPr/>
-        </p:nvSpPr>
-        <p:spPr>
-          <a:xfrm>
-            <a:off x="8415020" y="4770120"/>
-            <a:ext cx="3060700" cy="274320"/>
-          </a:xfrm>
-          <a:prstGeom prst="rect">
-            <a:avLst/>
-          </a:prstGeom>
-          <a:noFill/>
-          <a:ln/>
-        </p:spPr>
-        <p:txBody>
-          <a:bodyPr wrap="square" lIns="0" tIns="0" rIns="0" bIns="0" rtlCol="0" anchor="ctr"/>
-          <a:lstStyle/>
-          <a:p>
-            <a:pPr indent="0" marL="0">
-              <a:buNone/>
-            </a:pPr>
-            <a:r>
-              <a:rPr lang="en-US" sz="1100" b="1" spc="100" kern="0" dirty="0">
-                <a:solidFill>
-                  <a:srgbClr val="751B68"/>
-                </a:solidFill>
-                <a:latin typeface="Times New Roman" pitchFamily="34" charset="0"/>
-                <a:ea typeface="Times New Roman" pitchFamily="34" charset="-122"/>
-                <a:cs typeface="Times New Roman" pitchFamily="34" charset="-120"/>
-              </a:rPr>
-              <a:t>WHAT WE LEARN</a:t>
-            </a:r>
-            <a:endParaRPr lang="en-US" sz="1100" dirty="0"/>
-          </a:p>
-        </p:txBody>
-      </p:sp>
-      <p:sp>
-        <p:nvSpPr>
-          <p:cNvPr id="18" name="Text 15"/>
-          <p:cNvSpPr txBox="1"/>
-          <p:nvPr/>
-        </p:nvSpPr>
-        <p:spPr>
-          <a:xfrm>
-            <a:off x="8415020" y="5090160"/>
-            <a:ext cx="3060700" cy="807720"/>
-          </a:xfrm>
-          <a:prstGeom prst="rect">
-            <a:avLst/>
-          </a:prstGeom>
-          <a:noFill/>
-          <a:ln/>
-        </p:spPr>
-        <p:txBody>
-          <a:bodyPr wrap="square" lIns="0" tIns="0" rIns="0" bIns="0" rtlCol="0" anchor="t"/>
-          <a:lstStyle/>
-          <a:p>
-            <a:pPr indent="0" marL="0">
-              <a:lnSpc>
-                <a:spcPct val="118000"/>
-              </a:lnSpc>
-              <a:buNone/>
-            </a:pPr>
-            <a:r>
-              <a:rPr lang="en-US" sz="1350" dirty="0">
-                <a:solidFill>
-                  <a:srgbClr val="1F1D21"/>
-                </a:solidFill>
-                <a:latin typeface="Times New Roman" pitchFamily="34" charset="0"/>
-                <a:ea typeface="Times New Roman" pitchFamily="34" charset="-122"/>
-                <a:cs typeface="Times New Roman" pitchFamily="34" charset="-120"/>
-              </a:rPr>
               <a:t>[TODO] what this implies</a:t>
             </a:r>
             <a:endParaRPr lang="en-US" sz="1350" dirty="0"/>
@@ -4908,7 +4828,7 @@
       </p:sp>
       <p:pic>
         <p:nvPicPr>
-          <p:cNvPr id="19" name="Image 1" descr="/Users/bellavg/ProjectsMSc/ai4mi_project/deck/assets/uva_logo.png">    </p:cNvPr>
+          <p:cNvPr id="15" name="Image 1" descr="/Users/bellavg/ProjectsMSc/ai4mi_project/deck/assets/uva_logo.png">    </p:cNvPr>
           <p:cNvPicPr>
             <a:picLocks noChangeAspect="1"/>
           </p:cNvPicPr>
@@ -4932,7 +4852,7 @@
       </p:pic>
       <p:sp>
         <p:nvSpPr>
-          <p:cNvPr id="20" name="Text 16"/>
+          <p:cNvPr id="16" name="Text 12"/>
           <p:cNvSpPr txBox="1"/>
           <p:nvPr/>
         </p:nvSpPr>

</xml_diff>